<commit_message>
Align evaluation with dollar ranking and complete error-analysis slides
</commit_message>
<xml_diff>
--- a/docs/slides/Group11_deck.pptx
+++ b/docs/slides/Group11_deck.pptx
@@ -1127,7 +1127,7 @@
           <a:p>
             <a:r>
               <a:rPr lang="en-US" dirty="0"/>
-              <a:t>60 seconds. Answers Albert's 'how do you know it works' directly. The honest sentence about where it is weakest is the one the room respects.</a:t>
+              <a:t>60 seconds. We rebuilt the evaluation from the raw files and reproduced the headline. The left chart asks whether predicted return chances match reality. In the highest probability tenth, the model says 26.6 percent return and 24.2 percent do. The right chart follows the same dollar-ranked list as the headline: 23.6 percent return in 2017 and 20.9 percent in 2018, while the overall rate also falls. Dollars per selected donor fall from 140 to 103, but the model beats gift size in both years. Its limitation is coverage: donors giving under 50 dollars are half the population but just 0.55 percent of this list. The 14.4 percent figure belongs to the probability-only list, which finds more returners but fewer dollars. Source: evals/results/12_calibration_model.txt; notebook 04. First gift means total first-month giving. These are observations about frozen predictions, not new tuning.</a:t>
             </a:r>
             <a:endParaRPr lang="en-US" dirty="0"/>
           </a:p>
@@ -1215,7 +1215,7 @@
           <a:p>
             <a:r>
               <a:rPr lang="en-US" dirty="0"/>
-              <a:t>60 seconds. $25 is a PLACEHOLDER — replace with a cost per contact GoGood can defend, then re-run src/decision.py. Source: evals/results/11_decision_model.txt. Production cost is effectively zero; say so.</a:t>
+              <a:t>60 seconds. The 312 thousand dollar difference is giving identified in two historical lists of equal size, not incremental revenue caused by calls. The 25 dollar contact cost is a placeholder; Malorie supplies the real cost. The model was trained on log amounts, so its score is not a calibrated mean-dollar forecast. EV greater than cost is only illustrative. Source: evals/results/11_decision_model.txt. Compute uses no external model API; staff, setup and maintenance costs are not zero.</a:t>
             </a:r>
             <a:endParaRPr lang="en-US" dirty="0"/>
           </a:p>
@@ -1303,7 +1303,7 @@
           <a:p>
             <a:r>
               <a:rPr lang="en-US" dirty="0"/>
-              <a:t>50 seconds. Three things, plainly. Serves the insight question and the honesty Albert grades under 'technical contribution'.</a:t>
+              <a:t>50 seconds. Three limits matter for the recommendation. First, we can identify future giving, but we cannot say a call created it. Donors might have given anyway. The reported value less contact cost is therefore not a profit estimate. Second, we excluded the thank-you-packet flag because its timing is unknown; it might contain information recorded after the outcome. Third, we tested historical DonorsChoose donors, not today's donors at Malorie's customers. Transfer needs a local test. Before scaling, measure real staff costs and randomly assign outreach in a pilot so we can estimate additional giving caused by contact. The log-amount score also needs mean-dollar calibration before treating it as an absolute cost threshold. Sources: docs/ALBERT-FEEDBACK.md; src/model.py; src/decision.py; evals/results/12_calibration_model.txt.</a:t>
             </a:r>
             <a:endParaRPr lang="en-US" dirty="0"/>
           </a:p>
@@ -2170,7 +2170,7 @@
                 <a:ea typeface="Cambria" pitchFamily="34" charset="-122"/>
                 <a:cs typeface="Cambria" pitchFamily="34" charset="-120"/>
               </a:rPr>
-              <a:t>Rank each month's first-time donors by predicted second-gift value, call the top one in ten, and expect to reach 58 percent of next year's repeat giving.</a:t>
+              <a:t>Pilot the model-ranked list against gift-size ranking. The historical top 10% contained 58% of subsequent giving; test whether outreach adds donations before scaling.</a:t>
             </a:r>
             <a:endParaRPr lang="en-US" sz="2800" dirty="0"/>
           </a:p>
@@ -2561,7 +2561,7 @@
       </p:sp>
       <p:pic>
         <p:nvPicPr>
-          <p:cNvPr id="10" name="Image 0" descr="/Users/bakulbadwal/Documents/GitHub/gbus8496-project/docs/slides/assets/slide2_donations_per_donor_dark.png">    </p:cNvPr>
+          <p:cNvPr id="10" name="Image 0" descr="/Users/thadeusknospe/Library/CloudStorage/OneDrive-Personal/HSG/Exchange/UVA/Courses/Machine Learning/Group Project/docs/slides/assets/slide2_donations_per_donor_dark.png">    </p:cNvPr>
           <p:cNvPicPr>
             <a:picLocks noChangeAspect="1"/>
           </p:cNvPicPr>
@@ -3957,7 +3957,7 @@
       </p:sp>
       <p:pic>
         <p:nvPicPr>
-          <p:cNvPr id="10" name="Image 0" descr="/Users/bakulbadwal/Documents/GitHub/gbus8496-project/docs/slides/assets/slide4_donor_type_shares_dark.png">    </p:cNvPr>
+          <p:cNvPr id="10" name="Image 0" descr="/Users/thadeusknospe/Library/CloudStorage/OneDrive-Personal/HSG/Exchange/UVA/Courses/Machine Learning/Group Project/docs/slides/assets/slide4_donor_type_shares_dark.png">    </p:cNvPr>
           <p:cNvPicPr>
             <a:picLocks noChangeAspect="1"/>
           </p:cNvPicPr>
@@ -4881,7 +4881,7 @@
                           <a:ea typeface="Calibri" pitchFamily="34" charset="-122"/>
                           <a:cs typeface="Calibri" pitchFamily="34" charset="-120"/>
                         </a:rPr>
-                        <a:t>Our model — P(return) × E[amount]</a:t>
+                        <a:t>Our model — probability × amount score</a:t>
                       </a:r>
                       <a:endParaRPr lang="en-US" sz="1100" dirty="0">
                         <a:latin typeface="Calibri" charset="0"/>
@@ -4949,7 +4949,7 @@
                           <a:ea typeface="Calibri" pitchFamily="34" charset="-122"/>
                           <a:cs typeface="Calibri" pitchFamily="34" charset="-120"/>
                         </a:rPr>
-                        <a:t>22.2%</a:t>
+                        <a:t>22.1%</a:t>
                       </a:r>
                       <a:endParaRPr lang="en-US" sz="1100" dirty="0">
                         <a:latin typeface="Calibri" charset="0"/>
@@ -6613,7 +6613,7 @@
                 <a:ea typeface="Calibri" pitchFamily="34" charset="-122"/>
                 <a:cs typeface="Calibri" pitchFamily="34" charset="-120"/>
               </a:rPr>
-              <a:t>Paired bootstrap on the same donors: +$3.80 ± 0.51 per contact over gift size, about 7 standard errors. Real, and small — gift size already carries most of what predicts dollars. The baseline is fair: on a first-gift cohort, RFM collapses to gift size, and it is what she does by hand.</a:t>
+              <a:t>30 paired donor bootstrap samples: +$3.80 ± 0.51 per contact over gift size (±1 standard error). The 3.3% gain is modest; gift size already carries most of the dollar signal. The baseline is fair: on a first-gift cohort, RFM collapses to gift size, and it is what she does by hand.</a:t>
             </a:r>
             <a:endParaRPr lang="en-US" sz="1050" dirty="0"/>
           </a:p>
@@ -6738,7 +6738,7 @@
         <p:spPr>
           <a:xfrm>
             <a:off x="502920" y="621792"/>
-            <a:ext cx="8138160" cy="640080"/>
+            <a:ext cx="8138160" cy="548640"/>
           </a:xfrm>
           <a:prstGeom prst="rect">
             <a:avLst/>
@@ -6757,7 +6757,7 @@
               <a:buNone/>
             </a:pPr>
             <a:r>
-              <a:rPr lang="en-US" sz="2800" b="1" dirty="0">
+              <a:rPr lang="en-US" sz="2600" b="1" dirty="0">
                 <a:solidFill>
                   <a:srgbClr val="FFFFFF"/>
                 </a:solidFill>
@@ -6765,22 +6765,46 @@
                 <a:ea typeface="Cambria" pitchFamily="34" charset="-122"/>
                 <a:cs typeface="Cambria" pitchFamily="34" charset="-120"/>
               </a:rPr>
-              <a:t>How we know it works — and where it does not</a:t>
-            </a:r>
-            <a:endParaRPr lang="en-US" sz="2800" dirty="0"/>
-          </a:p>
-        </p:txBody>
-      </p:sp>
-      <p:sp>
-        <p:nvSpPr>
-          <p:cNvPr id="5" name="Text 3"/>
-          <p:cNvSpPr txBox="1"/>
-          <p:nvPr/>
-        </p:nvSpPr>
-        <p:spPr>
-          <a:xfrm>
-            <a:off x="502920" y="1280160"/>
-            <a:ext cx="3657600" cy="731520"/>
+              <a:t>The gain holds, but the dollar list favors large gifts</a:t>
+            </a:r>
+            <a:endParaRPr lang="en-US" sz="2600" dirty="0"/>
+          </a:p>
+        </p:txBody>
+      </p:sp>
+      <p:pic>
+        <p:nvPicPr>
+          <p:cNvPr id="5" name="Image 0" descr="/Users/thadeusknospe/Library/CloudStorage/OneDrive-Personal/HSG/Exchange/UVA/Courses/Machine Learning/Group Project/docs/slides/assets/slide7_calibration_model_dark.png">    </p:cNvPr>
+          <p:cNvPicPr>
+            <a:picLocks noChangeAspect="1"/>
+          </p:cNvPicPr>
+          <p:nvPr/>
+        </p:nvPicPr>
+        <p:blipFill>
+          <a:blip r:embed="rId1"/>
+          <a:stretch>
+            <a:fillRect/>
+          </a:stretch>
+        </p:blipFill>
+        <p:spPr>
+          <a:xfrm>
+            <a:off x="502920" y="1234440"/>
+            <a:ext cx="8138160" cy="3255264"/>
+          </a:xfrm>
+          <a:prstGeom prst="rect">
+            <a:avLst/>
+          </a:prstGeom>
+        </p:spPr>
+      </p:pic>
+      <p:sp>
+        <p:nvSpPr>
+          <p:cNvPr id="6" name="Text 3"/>
+          <p:cNvSpPr txBox="1"/>
+          <p:nvPr/>
+        </p:nvSpPr>
+        <p:spPr>
+          <a:xfrm>
+            <a:off x="502920" y="4562856"/>
+            <a:ext cx="8138160" cy="384048"/>
           </a:xfrm>
           <a:prstGeom prst="rect">
             <a:avLst/>
@@ -6799,7 +6823,7 @@
               <a:buNone/>
             </a:pPr>
             <a:r>
-              <a:rPr lang="en-US" sz="1300" i="1" dirty="0">
+              <a:rPr lang="en-US" sz="1050" dirty="0">
                 <a:solidFill>
                   <a:srgbClr val="C9A96A"/>
                 </a:solidFill>
@@ -6807,217 +6831,9 @@
                 <a:ea typeface="Calibri" pitchFamily="34" charset="-122"/>
                 <a:cs typeface="Calibri" pitchFamily="34" charset="-120"/>
               </a:rPr>
-              <a:t>It is calibrated here, it is not calibrated there, and it is weakest on exactly the donors she cares about most.</a:t>
-            </a:r>
-            <a:endParaRPr lang="en-US" sz="1300" dirty="0"/>
-          </a:p>
-        </p:txBody>
-      </p:sp>
-      <p:sp>
-        <p:nvSpPr>
-          <p:cNvPr id="6" name="Text 4"/>
-          <p:cNvSpPr txBox="1"/>
-          <p:nvPr/>
-        </p:nvSpPr>
-        <p:spPr>
-          <a:xfrm>
-            <a:off x="502920" y="2103120"/>
-            <a:ext cx="3291840" cy="1188720"/>
-          </a:xfrm>
-          <a:prstGeom prst="rect">
-            <a:avLst/>
-          </a:prstGeom>
-          <a:noFill/>
-          <a:ln/>
-        </p:spPr>
-        <p:txBody>
-          <a:bodyPr wrap="square" lIns="0" tIns="0" rIns="0" bIns="0" rtlCol="0" anchor="t"/>
-          <a:lstStyle/>
-          <a:p>
-            <a:pPr algn="l" indent="0" marL="0">
-              <a:lnSpc>
-                <a:spcPct val="115000"/>
-              </a:lnSpc>
-              <a:buNone/>
-            </a:pPr>
-            <a:r>
-              <a:rPr lang="en-US" sz="1100" dirty="0">
-                <a:solidFill>
-                  <a:srgbClr val="D9D3C6"/>
-                </a:solidFill>
-                <a:latin typeface="Calibri" pitchFamily="34" charset="0"/>
-                <a:ea typeface="Calibri" pitchFamily="34" charset="-122"/>
-                <a:cs typeface="Calibri" pitchFamily="34" charset="-120"/>
-              </a:rPr>
-              <a:t>Calibration curve on the holdout. Error analysis by cohort year — does 2018 behave like 2015? — and by first-gift size band, where most of her donors live.</a:t>
-            </a:r>
-            <a:endParaRPr lang="en-US" sz="1100" dirty="0"/>
-          </a:p>
-        </p:txBody>
-      </p:sp>
-      <p:sp>
-        <p:nvSpPr>
-          <p:cNvPr id="7" name="Shape 5"/>
-          <p:cNvSpPr/>
-          <p:nvPr/>
-        </p:nvSpPr>
-        <p:spPr>
-          <a:xfrm>
-            <a:off x="4160520" y="1188720"/>
-            <a:ext cx="2148840" cy="3520440"/>
-          </a:xfrm>
-          <a:prstGeom prst="roundRect">
-            <a:avLst>
-              <a:gd name="adj" fmla="val 2553"/>
-            </a:avLst>
-          </a:prstGeom>
-          <a:solidFill>
-            <a:srgbClr val="081321"/>
-          </a:solidFill>
-          <a:ln w="9525">
-            <a:solidFill>
-              <a:srgbClr val="C9A96A"/>
-            </a:solidFill>
-            <a:prstDash val="dash"/>
-          </a:ln>
-        </p:spPr>
-      </p:sp>
-      <p:sp>
-        <p:nvSpPr>
-          <p:cNvPr id="8" name="Text 6"/>
-          <p:cNvSpPr txBox="1"/>
-          <p:nvPr/>
-        </p:nvSpPr>
-        <p:spPr>
-          <a:xfrm>
-            <a:off x="4343400" y="1371600"/>
-            <a:ext cx="1783080" cy="3154680"/>
-          </a:xfrm>
-          <a:prstGeom prst="rect">
-            <a:avLst/>
-          </a:prstGeom>
-          <a:noFill/>
-          <a:ln/>
-        </p:spPr>
-        <p:txBody>
-          <a:bodyPr wrap="square" lIns="0" tIns="0" rIns="0" bIns="0" rtlCol="0" anchor="ctr"/>
-          <a:lstStyle/>
-          <a:p>
-            <a:pPr algn="ctr" indent="0" marL="0">
-              <a:buNone/>
-            </a:pPr>
-            <a:r>
-              <a:rPr lang="en-US" sz="800" spc="200" kern="0" dirty="0">
-                <a:solidFill>
-                  <a:srgbClr val="C9A96A"/>
-                </a:solidFill>
-                <a:latin typeface="Courier New" pitchFamily="34" charset="0"/>
-                <a:ea typeface="Courier New" pitchFamily="34" charset="-122"/>
-                <a:cs typeface="Courier New" pitchFamily="34" charset="-120"/>
-              </a:rPr>
-              <a:t>DROP HERE</a:t>
-            </a:r>
-            <a:endParaRPr lang="en-US" sz="800" dirty="0"/>
-          </a:p>
-          <a:p>
-            <a:pPr algn="ctr" indent="0" marL="0">
-              <a:buNone/>
-            </a:pPr>
-            <a:r>
-              <a:rPr lang="en-US" sz="1200" i="1" dirty="0">
-                <a:solidFill>
-                  <a:srgbClr val="B4AE9F"/>
-                </a:solidFill>
-                <a:latin typeface="Calibri" pitchFamily="34" charset="0"/>
-                <a:ea typeface="Calibri" pitchFamily="34" charset="-122"/>
-                <a:cs typeface="Calibri" pitchFamily="34" charset="-120"/>
-              </a:rPr>
-              <a:t>Calibration curve</a:t>
-            </a:r>
-            <a:endParaRPr lang="en-US" sz="800" dirty="0"/>
-          </a:p>
-        </p:txBody>
-      </p:sp>
-      <p:sp>
-        <p:nvSpPr>
-          <p:cNvPr id="9" name="Shape 7"/>
-          <p:cNvSpPr/>
-          <p:nvPr/>
-        </p:nvSpPr>
-        <p:spPr>
-          <a:xfrm>
-            <a:off x="6492240" y="1188720"/>
-            <a:ext cx="2148840" cy="3520440"/>
-          </a:xfrm>
-          <a:prstGeom prst="roundRect">
-            <a:avLst>
-              <a:gd name="adj" fmla="val 2553"/>
-            </a:avLst>
-          </a:prstGeom>
-          <a:solidFill>
-            <a:srgbClr val="081321"/>
-          </a:solidFill>
-          <a:ln w="9525">
-            <a:solidFill>
-              <a:srgbClr val="C9A96A"/>
-            </a:solidFill>
-            <a:prstDash val="dash"/>
-          </a:ln>
-        </p:spPr>
-      </p:sp>
-      <p:sp>
-        <p:nvSpPr>
-          <p:cNvPr id="10" name="Text 8"/>
-          <p:cNvSpPr txBox="1"/>
-          <p:nvPr/>
-        </p:nvSpPr>
-        <p:spPr>
-          <a:xfrm>
-            <a:off x="6675120" y="1371600"/>
-            <a:ext cx="1783080" cy="3154680"/>
-          </a:xfrm>
-          <a:prstGeom prst="rect">
-            <a:avLst/>
-          </a:prstGeom>
-          <a:noFill/>
-          <a:ln/>
-        </p:spPr>
-        <p:txBody>
-          <a:bodyPr wrap="square" lIns="0" tIns="0" rIns="0" bIns="0" rtlCol="0" anchor="ctr"/>
-          <a:lstStyle/>
-          <a:p>
-            <a:pPr algn="ctr" indent="0" marL="0">
-              <a:buNone/>
-            </a:pPr>
-            <a:r>
-              <a:rPr lang="en-US" sz="800" spc="200" kern="0" dirty="0">
-                <a:solidFill>
-                  <a:srgbClr val="C9A96A"/>
-                </a:solidFill>
-                <a:latin typeface="Courier New" pitchFamily="34" charset="0"/>
-                <a:ea typeface="Courier New" pitchFamily="34" charset="-122"/>
-                <a:cs typeface="Courier New" pitchFamily="34" charset="-120"/>
-              </a:rPr>
-              <a:t>DROP HERE</a:t>
-            </a:r>
-            <a:endParaRPr lang="en-US" sz="800" dirty="0"/>
-          </a:p>
-          <a:p>
-            <a:pPr algn="ctr" indent="0" marL="0">
-              <a:buNone/>
-            </a:pPr>
-            <a:r>
-              <a:rPr lang="en-US" sz="1200" i="1" dirty="0">
-                <a:solidFill>
-                  <a:srgbClr val="B4AE9F"/>
-                </a:solidFill>
-                <a:latin typeface="Calibri" pitchFamily="34" charset="0"/>
-                <a:ea typeface="Calibri" pitchFamily="34" charset="-122"/>
-                <a:cs typeface="Calibri" pitchFamily="34" charset="-120"/>
-              </a:rPr>
-              <a:t>Error by cohort year / gift band</a:t>
-            </a:r>
-            <a:endParaRPr lang="en-US" sz="800" dirty="0"/>
+              <a:t>Under-$50 donors: 52.4% of the holdout, only 0.55% of the dollar-ranked list (14.4% if ranked by probability).</a:t>
+            </a:r>
+            <a:endParaRPr lang="en-US" sz="1050" dirty="0"/>
           </a:p>
         </p:txBody>
       </p:sp>
@@ -7272,7 +7088,7 @@
                 <a:ea typeface="Courier New" pitchFamily="34" charset="-122"/>
                 <a:cs typeface="Courier New" pitchFamily="34" charset="-120"/>
               </a:rPr>
-              <a:t>CALLS · DEC 2018</a:t>
+              <a:t>SELECTED · DEC 2018</a:t>
             </a:r>
             <a:endParaRPr lang="en-US" sz="800" dirty="0"/>
           </a:p>
@@ -7443,7 +7259,7 @@
                 <a:ea typeface="Cambria" pitchFamily="34" charset="-122"/>
                 <a:cs typeface="Cambria" pitchFamily="34" charset="-120"/>
               </a:rPr>
-              <a:t>+$7.75M</a:t>
+              <a:t>$7.75M</a:t>
             </a:r>
             <a:endParaRPr lang="en-US" sz="2800" dirty="0"/>
           </a:p>
@@ -7482,7 +7298,7 @@
                 <a:ea typeface="Courier New" pitchFamily="34" charset="-122"/>
                 <a:cs typeface="Courier New" pitchFamily="34" charset="-120"/>
               </a:rPr>
-              <a:t>NET · 2017–18</a:t>
+              <a:t>VALUE LESS ASSUMED COST</a:t>
             </a:r>
             <a:endParaRPr lang="en-US" sz="800" dirty="0"/>
           </a:p>
@@ -7548,7 +7364,7 @@
                 <a:ea typeface="Cambria" pitchFamily="34" charset="-122"/>
                 <a:cs typeface="Cambria" pitchFamily="34" charset="-120"/>
               </a:rPr>
-              <a:t>$0</a:t>
+              <a:t>No API</a:t>
             </a:r>
             <a:endParaRPr lang="en-US" sz="2800" dirty="0"/>
           </a:p>
@@ -7587,7 +7403,7 @@
                 <a:ea typeface="Courier New" pitchFamily="34" charset="-122"/>
                 <a:cs typeface="Courier New" pitchFamily="34" charset="-120"/>
               </a:rPr>
-              <a:t>TO RUN MONTHLY</a:t>
+              <a:t>EXTERNAL MODEL CALLS</a:t>
             </a:r>
             <a:endParaRPr lang="en-US" sz="800" dirty="0"/>
           </a:p>
@@ -7629,7 +7445,7 @@
                 <a:ea typeface="Calibri" pitchFamily="34" charset="-122"/>
                 <a:cs typeface="Calibri" pitchFamily="34" charset="-120"/>
               </a:rPr>
-              <a:t>Calling everyone loses $3.6M at $25 a contact. Calling the model's top 10% nets $7.75M over the two holdout years — $312K more than her gift-size rule on the same number of calls. Her cost per contact sets how deep to go: at $5, half of new donors clear break-even; at $25, 6.5%.</a:t>
+              <a:t>The model's list contains $9.79M of subsequent giving. Subtracting $2.04M of hypothetical contact costs leaves $7.75M, versus $7.44M for gift-size ranking. Neither balance measures outreach profit: we do not know how much extra giving a call causes.</a:t>
             </a:r>
             <a:endParaRPr lang="en-US" sz="1200" dirty="0"/>
           </a:p>
@@ -7737,7 +7553,7 @@
                 <a:ea typeface="Calibri" pitchFamily="34" charset="-122"/>
                 <a:cs typeface="Calibri" pitchFamily="34" charset="-120"/>
               </a:rPr>
-              <a:t>One monthly batch job on a laptop: about ten minutes, no API calls, no vendor. The only real cost is her time on the phone.</a:t>
+              <a:t>Scoring runs locally without API fees. Staff outreach, setup and maintenance still cost money. Replace the $25 contact-cost assumption with evidence from practice.</a:t>
             </a:r>
             <a:endParaRPr lang="en-US" sz="1200" dirty="0"/>
           </a:p>
@@ -7997,7 +7813,7 @@
                 <a:ea typeface="Calibri" pitchFamily="34" charset="-122"/>
                 <a:cs typeface="Calibri" pitchFamily="34" charset="-120"/>
               </a:rPr>
-              <a:t>No causal claim</a:t>
+              <a:t>Outreach impact is unknown</a:t>
             </a:r>
             <a:endParaRPr lang="en-US" sz="1300" dirty="0"/>
           </a:p>
@@ -8039,7 +7855,7 @@
                 <a:ea typeface="Calibri" pitchFamily="34" charset="-122"/>
                 <a:cs typeface="Calibri" pitchFamily="34" charset="-120"/>
               </a:rPr>
-              <a:t>Nobody was randomly assigned to be contacted. We rank by predicted future value and say “identified”, never “caused”.</a:t>
+              <a:t>The records show who gave again, not what a call changed. Dollars identified minus assumed contact cost is not measured profit.</a:t>
             </a:r>
             <a:endParaRPr lang="en-US" sz="1050" dirty="0"/>
           </a:p>
@@ -8297,7 +8113,7 @@
                 <a:ea typeface="Calibri" pitchFamily="34" charset="-122"/>
                 <a:cs typeface="Calibri" pitchFamily="34" charset="-120"/>
               </a:rPr>
-              <a:t>Transfer is a hypothesis</a:t>
+              <a:t>Transfer is untested</a:t>
             </a:r>
             <a:endParaRPr lang="en-US" sz="1300" dirty="0"/>
           </a:p>
@@ -8339,9 +8155,51 @@
                 <a:ea typeface="Calibri" pitchFamily="34" charset="-122"/>
                 <a:cs typeface="Calibri" pitchFamily="34" charset="-120"/>
               </a:rPr>
-              <a:t>DonorsChoose donors are marketplace donors; small-nonprofit donors are relational. Behavioural features likely transfer; platform-specific ones likely do not.</a:t>
+              <a:t>We tested 2017–18 DonorsChoose cohorts. Performance for today’s donors or another nonprofit has not been established.</a:t>
             </a:r>
             <a:endParaRPr lang="en-US" sz="1050" dirty="0"/>
+          </a:p>
+        </p:txBody>
+      </p:sp>
+      <p:sp>
+        <p:nvSpPr>
+          <p:cNvPr id="17" name="Text 15"/>
+          <p:cNvSpPr txBox="1"/>
+          <p:nvPr/>
+        </p:nvSpPr>
+        <p:spPr>
+          <a:xfrm>
+            <a:off x="502920" y="4507992"/>
+            <a:ext cx="8138160" cy="365760"/>
+          </a:xfrm>
+          <a:prstGeom prst="rect">
+            <a:avLst/>
+          </a:prstGeom>
+          <a:noFill/>
+          <a:ln/>
+        </p:spPr>
+        <p:txBody>
+          <a:bodyPr wrap="square" lIns="0" tIns="0" rIns="0" bIns="0" rtlCol="0" anchor="t"/>
+          <a:lstStyle/>
+          <a:p>
+            <a:pPr algn="l" indent="0" marL="0">
+              <a:lnSpc>
+                <a:spcPct val="115000"/>
+              </a:lnSpc>
+              <a:buNone/>
+            </a:pPr>
+            <a:r>
+              <a:rPr lang="en-US" sz="1100" dirty="0">
+                <a:solidFill>
+                  <a:srgbClr val="C9A96A"/>
+                </a:solidFill>
+                <a:latin typeface="Calibri" pitchFamily="34" charset="0"/>
+                <a:ea typeface="Calibri" pitchFamily="34" charset="-122"/>
+                <a:cs typeface="Calibri" pitchFamily="34" charset="-120"/>
+              </a:rPr>
+              <a:t>Next: validate locally, measure real contact costs, and test randomized outreach before scaling.</a:t>
+            </a:r>
+            <a:endParaRPr lang="en-US" sz="1100" dirty="0"/>
           </a:p>
         </p:txBody>
       </p:sp>

</xml_diff>